<commit_message>
docs: link verified Google Drive technical report and demonstration video walkthrough across README, executive brief, and presentation deck
</commit_message>
<xml_diff>
--- a/docs/MonsoonGuard_SIH2026.pptx
+++ b/docs/MonsoonGuard_SIH2026.pptx
@@ -3381,7 +3381,7 @@
                   <a:srgbClr val="0F172A"/>
                 </a:solidFill>
               </a:rPr>
-              <a:t>Target Workforces: </a:t>
+              <a:t>Live Frontend URL: </a:t>
             </a:r>
             <a:r>
               <a:rPr b="0" sz="1100">
@@ -3389,7 +3389,7 @@
                   <a:srgbClr val="334155"/>
                 </a:solidFill>
               </a:rPr>
-              <a:t>140M+ Indian Farmers, KVKs, District Agriculture Officers</a:t>
+              <a:t>https://monsoonguard-system.vercel.app/</a:t>
             </a:r>
           </a:p>
           <a:p>
@@ -3404,7 +3404,7 @@
                   <a:srgbClr val="0F172A"/>
                 </a:solidFill>
               </a:rPr>
-              <a:t>Live Frontend URL: </a:t>
+              <a:t>Live Backend API: </a:t>
             </a:r>
             <a:r>
               <a:rPr b="0" sz="1100">
@@ -3412,7 +3412,7 @@
                   <a:srgbClr val="334155"/>
                 </a:solidFill>
               </a:rPr>
-              <a:t>https://monsoonguard-system.vercel.app/</a:t>
+              <a:t>https://monsoonguard-system.onrender.com/docs</a:t>
             </a:r>
           </a:p>
           <a:p>
@@ -3427,7 +3427,7 @@
                   <a:srgbClr val="0F172A"/>
                 </a:solidFill>
               </a:rPr>
-              <a:t>Live Backend API: </a:t>
+              <a:t>Technical Report (PDF): </a:t>
             </a:r>
             <a:r>
               <a:rPr b="0" sz="1100">
@@ -3435,7 +3435,30 @@
                   <a:srgbClr val="334155"/>
                 </a:solidFill>
               </a:rPr>
-              <a:t>https://monsoonguard-system.onrender.com/docs</a:t>
+              <a:t>https://drive.google.com/file/d/1fH54z9E90YvwI5SwaRdL1u5-AXliAjqK/view?usp=sharing</a:t>
+            </a:r>
+          </a:p>
+          <a:p>
+            <a:pPr>
+              <a:spcAft>
+                <a:spcPts val="800"/>
+              </a:spcAft>
+            </a:pPr>
+            <a:r>
+              <a:rPr b="1" sz="1200">
+                <a:solidFill>
+                  <a:srgbClr val="0F172A"/>
+                </a:solidFill>
+              </a:rPr>
+              <a:t>Demo Video Walkthrough: </a:t>
+            </a:r>
+            <a:r>
+              <a:rPr b="0" sz="1100">
+                <a:solidFill>
+                  <a:srgbClr val="334155"/>
+                </a:solidFill>
+              </a:rPr>
+              <a:t>https://drive.google.com/file/d/11RcsCXPiOgg9B4bcHfbTABs25oBDbCiB/view?usp=sharing</a:t>
             </a:r>
           </a:p>
         </p:txBody>

</xml_diff>